<commit_message>
fix typos in slides gbt
</commit_message>
<xml_diff>
--- a/slides/gbt.pptx
+++ b/slides/gbt.pptx
@@ -325,7 +325,7 @@
               <a:pPr>
                 <a:defRPr/>
               </a:pPr>
-              <a:t>20-04-2026</a:t>
+              <a:t>23-04-2026</a:t>
             </a:fld>
             <a:endParaRPr lang="en-US"/>
           </a:p>
@@ -3986,7 +3986,7 @@
               <a:pPr>
                 <a:defRPr/>
               </a:pPr>
-              <a:t>20-04-2026</a:t>
+              <a:t>23-04-2026</a:t>
             </a:fld>
             <a:endParaRPr lang="en-US"/>
           </a:p>
@@ -4176,7 +4176,7 @@
               <a:pPr>
                 <a:defRPr/>
               </a:pPr>
-              <a:t>20-04-2026</a:t>
+              <a:t>23-04-2026</a:t>
             </a:fld>
             <a:endParaRPr lang="en-US"/>
           </a:p>
@@ -4376,7 +4376,7 @@
               <a:pPr>
                 <a:defRPr/>
               </a:pPr>
-              <a:t>20-04-2026</a:t>
+              <a:t>23-04-2026</a:t>
             </a:fld>
             <a:endParaRPr lang="en-US"/>
           </a:p>
@@ -4572,7 +4572,7 @@
               <a:pPr>
                 <a:defRPr/>
               </a:pPr>
-              <a:t>20-04-2026</a:t>
+              <a:t>23-04-2026</a:t>
             </a:fld>
             <a:endParaRPr lang="en-US"/>
           </a:p>
@@ -4839,7 +4839,7 @@
               <a:pPr>
                 <a:defRPr/>
               </a:pPr>
-              <a:t>20-04-2026</a:t>
+              <a:t>23-04-2026</a:t>
             </a:fld>
             <a:endParaRPr lang="en-US"/>
           </a:p>
@@ -5146,7 +5146,7 @@
               <a:pPr>
                 <a:defRPr/>
               </a:pPr>
-              <a:t>20-04-2026</a:t>
+              <a:t>23-04-2026</a:t>
             </a:fld>
             <a:endParaRPr lang="en-US"/>
           </a:p>
@@ -5587,7 +5587,7 @@
               <a:pPr>
                 <a:defRPr/>
               </a:pPr>
-              <a:t>20-04-2026</a:t>
+              <a:t>23-04-2026</a:t>
             </a:fld>
             <a:endParaRPr lang="en-US"/>
           </a:p>
@@ -5732,7 +5732,7 @@
               <a:pPr>
                 <a:defRPr/>
               </a:pPr>
-              <a:t>20-04-2026</a:t>
+              <a:t>23-04-2026</a:t>
             </a:fld>
             <a:endParaRPr lang="en-US"/>
           </a:p>
@@ -5849,7 +5849,7 @@
               <a:pPr>
                 <a:defRPr/>
               </a:pPr>
-              <a:t>20-04-2026</a:t>
+              <a:t>23-04-2026</a:t>
             </a:fld>
             <a:endParaRPr lang="en-US"/>
           </a:p>
@@ -6146,7 +6146,7 @@
               <a:pPr>
                 <a:defRPr/>
               </a:pPr>
-              <a:t>20-04-2026</a:t>
+              <a:t>23-04-2026</a:t>
             </a:fld>
             <a:endParaRPr lang="en-US"/>
           </a:p>
@@ -6426,7 +6426,7 @@
               <a:pPr>
                 <a:defRPr/>
               </a:pPr>
-              <a:t>20-04-2026</a:t>
+              <a:t>23-04-2026</a:t>
             </a:fld>
             <a:endParaRPr lang="en-US"/>
           </a:p>
@@ -6682,7 +6682,7 @@
               <a:pPr>
                 <a:defRPr/>
               </a:pPr>
-              <a:t>20-04-2026</a:t>
+              <a:t>23-04-2026</a:t>
             </a:fld>
             <a:endParaRPr lang="en-US"/>
           </a:p>
@@ -10402,7 +10402,11 @@
             <a:bodyPr wrap="none" anchor="ctr"/>
             <a:lstStyle/>
             <a:p>
-              <a:endParaRPr lang="nl-NL"/>
+              <a:endParaRPr lang="nl-NL">
+                <a:solidFill>
+                  <a:srgbClr val="FFFF00"/>
+                </a:solidFill>
+              </a:endParaRPr>
             </a:p>
           </p:txBody>
         </p:sp>
@@ -10416,8 +10420,8 @@
           </p:nvSpPr>
           <p:spPr bwMode="auto">
             <a:xfrm>
-              <a:off x="4365" y="1769"/>
-              <a:ext cx="196" cy="250"/>
+              <a:off x="4364" y="1769"/>
+              <a:ext cx="197" cy="233"/>
             </a:xfrm>
             <a:prstGeom prst="rect">
               <a:avLst/>
@@ -10438,7 +10442,11 @@
             <a:p>
               <a:pPr algn="r"/>
               <a:r>
-                <a:rPr lang="en-US"/>
+                <a:rPr lang="en-US">
+                  <a:solidFill>
+                    <a:srgbClr val="FFFF00"/>
+                  </a:solidFill>
+                </a:rPr>
                 <a:t>1</a:t>
               </a:r>
             </a:p>
@@ -10591,7 +10599,11 @@
             <a:bodyPr wrap="none" anchor="ctr"/>
             <a:lstStyle/>
             <a:p>
-              <a:endParaRPr lang="nl-NL"/>
+              <a:endParaRPr lang="nl-NL">
+                <a:solidFill>
+                  <a:srgbClr val="FFFF00"/>
+                </a:solidFill>
+              </a:endParaRPr>
             </a:p>
           </p:txBody>
         </p:sp>
@@ -10606,7 +10618,7 @@
           <p:spPr bwMode="auto">
             <a:xfrm>
               <a:off x="3915" y="2707"/>
-              <a:ext cx="196" cy="250"/>
+              <a:ext cx="197" cy="233"/>
             </a:xfrm>
             <a:prstGeom prst="rect">
               <a:avLst/>
@@ -10626,7 +10638,11 @@
             <a:lstStyle/>
             <a:p>
               <a:r>
-                <a:rPr lang="en-US"/>
+                <a:rPr lang="en-US">
+                  <a:solidFill>
+                    <a:srgbClr val="FFFF00"/>
+                  </a:solidFill>
+                </a:rPr>
                 <a:t>0</a:t>
               </a:r>
             </a:p>
@@ -10817,7 +10833,11 @@
             <a:bodyPr wrap="none" anchor="ctr"/>
             <a:lstStyle/>
             <a:p>
-              <a:endParaRPr lang="nl-NL"/>
+              <a:endParaRPr lang="nl-NL">
+                <a:solidFill>
+                  <a:srgbClr val="FFFF00"/>
+                </a:solidFill>
+              </a:endParaRPr>
             </a:p>
           </p:txBody>
         </p:sp>
@@ -10831,8 +10851,8 @@
           </p:nvSpPr>
           <p:spPr bwMode="auto">
             <a:xfrm>
-              <a:off x="4365" y="1769"/>
-              <a:ext cx="196" cy="250"/>
+              <a:off x="4364" y="1769"/>
+              <a:ext cx="197" cy="233"/>
             </a:xfrm>
             <a:prstGeom prst="rect">
               <a:avLst/>
@@ -10853,7 +10873,11 @@
             <a:p>
               <a:pPr algn="r"/>
               <a:r>
-                <a:rPr lang="en-US"/>
+                <a:rPr lang="en-US">
+                  <a:solidFill>
+                    <a:srgbClr val="FFFF00"/>
+                  </a:solidFill>
+                </a:rPr>
                 <a:t>0</a:t>
               </a:r>
             </a:p>
@@ -10924,7 +10948,11 @@
               <a:bodyPr wrap="none" anchor="ctr"/>
               <a:lstStyle/>
               <a:p>
-                <a:endParaRPr lang="nl-NL"/>
+                <a:endParaRPr lang="nl-NL">
+                  <a:solidFill>
+                    <a:srgbClr val="FFFF00"/>
+                  </a:solidFill>
+                </a:endParaRPr>
               </a:p>
             </p:txBody>
           </p:sp>
@@ -10939,7 +10967,7 @@
             <p:spPr bwMode="auto">
               <a:xfrm>
                 <a:off x="4815" y="2707"/>
-                <a:ext cx="196" cy="250"/>
+                <a:ext cx="197" cy="233"/>
               </a:xfrm>
               <a:prstGeom prst="rect">
                 <a:avLst/>
@@ -10959,7 +10987,11 @@
               <a:lstStyle/>
               <a:p>
                 <a:r>
-                  <a:rPr lang="en-US"/>
+                  <a:rPr lang="en-US">
+                    <a:solidFill>
+                      <a:srgbClr val="FFFF00"/>
+                    </a:solidFill>
+                  </a:rPr>
                   <a:t>2</a:t>
                 </a:r>
               </a:p>
@@ -11014,7 +11046,11 @@
               <a:bodyPr wrap="none" anchor="ctr"/>
               <a:lstStyle/>
               <a:p>
-                <a:endParaRPr lang="nl-NL"/>
+                <a:endParaRPr lang="nl-NL">
+                  <a:solidFill>
+                    <a:srgbClr val="FFFF00"/>
+                  </a:solidFill>
+                </a:endParaRPr>
               </a:p>
             </p:txBody>
           </p:sp>
@@ -11029,7 +11065,7 @@
             <p:spPr bwMode="auto">
               <a:xfrm>
                 <a:off x="3915" y="2707"/>
-                <a:ext cx="196" cy="250"/>
+                <a:ext cx="197" cy="233"/>
               </a:xfrm>
               <a:prstGeom prst="rect">
                 <a:avLst/>
@@ -11049,7 +11085,11 @@
               <a:lstStyle/>
               <a:p>
                 <a:r>
-                  <a:rPr lang="en-US"/>
+                  <a:rPr lang="en-US">
+                    <a:solidFill>
+                      <a:srgbClr val="FFFF00"/>
+                    </a:solidFill>
+                  </a:rPr>
                   <a:t>1</a:t>
                 </a:r>
               </a:p>
@@ -11271,7 +11311,11 @@
             <a:bodyPr wrap="none" anchor="ctr"/>
             <a:lstStyle/>
             <a:p>
-              <a:endParaRPr lang="nl-NL"/>
+              <a:endParaRPr lang="nl-NL">
+                <a:solidFill>
+                  <a:srgbClr val="FFFF00"/>
+                </a:solidFill>
+              </a:endParaRPr>
             </a:p>
           </p:txBody>
         </p:sp>
@@ -11285,8 +11329,8 @@
           </p:nvSpPr>
           <p:spPr bwMode="auto">
             <a:xfrm>
-              <a:off x="4365" y="1769"/>
-              <a:ext cx="196" cy="250"/>
+              <a:off x="4364" y="1769"/>
+              <a:ext cx="197" cy="233"/>
             </a:xfrm>
             <a:prstGeom prst="rect">
               <a:avLst/>
@@ -11307,7 +11351,11 @@
             <a:p>
               <a:pPr algn="r"/>
               <a:r>
-                <a:rPr lang="en-US"/>
+                <a:rPr lang="en-US">
+                  <a:solidFill>
+                    <a:srgbClr val="FFFF00"/>
+                  </a:solidFill>
+                </a:rPr>
                 <a:t>3</a:t>
               </a:r>
             </a:p>
@@ -11378,7 +11426,11 @@
               <a:bodyPr wrap="none" anchor="ctr"/>
               <a:lstStyle/>
               <a:p>
-                <a:endParaRPr lang="nl-NL"/>
+                <a:endParaRPr lang="nl-NL">
+                  <a:solidFill>
+                    <a:srgbClr val="FFFF00"/>
+                  </a:solidFill>
+                </a:endParaRPr>
               </a:p>
             </p:txBody>
           </p:sp>
@@ -11393,7 +11445,7 @@
             <p:spPr bwMode="auto">
               <a:xfrm>
                 <a:off x="4815" y="2707"/>
-                <a:ext cx="196" cy="250"/>
+                <a:ext cx="197" cy="233"/>
               </a:xfrm>
               <a:prstGeom prst="rect">
                 <a:avLst/>
@@ -11413,7 +11465,11 @@
               <a:lstStyle/>
               <a:p>
                 <a:r>
-                  <a:rPr lang="en-US"/>
+                  <a:rPr lang="en-US">
+                    <a:solidFill>
+                      <a:srgbClr val="FFFF00"/>
+                    </a:solidFill>
+                  </a:rPr>
                   <a:t>5</a:t>
                 </a:r>
               </a:p>
@@ -11468,7 +11524,11 @@
               <a:bodyPr wrap="none" anchor="ctr"/>
               <a:lstStyle/>
               <a:p>
-                <a:endParaRPr lang="nl-NL"/>
+                <a:endParaRPr lang="nl-NL">
+                  <a:solidFill>
+                    <a:srgbClr val="FFFF00"/>
+                  </a:solidFill>
+                </a:endParaRPr>
               </a:p>
             </p:txBody>
           </p:sp>
@@ -11483,7 +11543,7 @@
             <p:spPr bwMode="auto">
               <a:xfrm>
                 <a:off x="3915" y="2707"/>
-                <a:ext cx="196" cy="250"/>
+                <a:ext cx="197" cy="233"/>
               </a:xfrm>
               <a:prstGeom prst="rect">
                 <a:avLst/>
@@ -11503,7 +11563,11 @@
               <a:lstStyle/>
               <a:p>
                 <a:r>
-                  <a:rPr lang="en-US"/>
+                  <a:rPr lang="en-US">
+                    <a:solidFill>
+                      <a:srgbClr val="FFFF00"/>
+                    </a:solidFill>
+                  </a:rPr>
                   <a:t>4</a:t>
                 </a:r>
               </a:p>
@@ -12576,7 +12640,11 @@
             <a:bodyPr wrap="none" anchor="ctr"/>
             <a:lstStyle/>
             <a:p>
-              <a:endParaRPr lang="nl-NL"/>
+              <a:endParaRPr lang="nl-NL">
+                <a:solidFill>
+                  <a:srgbClr val="FFFF00"/>
+                </a:solidFill>
+              </a:endParaRPr>
             </a:p>
           </p:txBody>
         </p:sp>
@@ -12596,8 +12664,8 @@
           </p:nvSpPr>
           <p:spPr bwMode="auto">
             <a:xfrm>
-              <a:off x="4365" y="1769"/>
-              <a:ext cx="196" cy="250"/>
+              <a:off x="4364" y="1769"/>
+              <a:ext cx="197" cy="233"/>
             </a:xfrm>
             <a:prstGeom prst="rect">
               <a:avLst/>
@@ -12618,7 +12686,11 @@
             <a:p>
               <a:pPr algn="r"/>
               <a:r>
-                <a:rPr lang="en-US"/>
+                <a:rPr lang="en-US">
+                  <a:solidFill>
+                    <a:srgbClr val="FFFF00"/>
+                  </a:solidFill>
+                </a:rPr>
                 <a:t>1</a:t>
               </a:r>
             </a:p>
@@ -12707,7 +12779,11 @@
               <a:bodyPr wrap="none" anchor="ctr"/>
               <a:lstStyle/>
               <a:p>
-                <a:endParaRPr lang="nl-NL"/>
+                <a:endParaRPr lang="nl-NL">
+                  <a:solidFill>
+                    <a:srgbClr val="FFFF00"/>
+                  </a:solidFill>
+                </a:endParaRPr>
               </a:p>
             </p:txBody>
           </p:sp>
@@ -12728,7 +12804,7 @@
             <p:spPr bwMode="auto">
               <a:xfrm>
                 <a:off x="4815" y="2707"/>
-                <a:ext cx="196" cy="250"/>
+                <a:ext cx="197" cy="233"/>
               </a:xfrm>
               <a:prstGeom prst="rect">
                 <a:avLst/>
@@ -12748,7 +12824,11 @@
               <a:lstStyle/>
               <a:p>
                 <a:r>
-                  <a:rPr lang="en-US"/>
+                  <a:rPr lang="en-US">
+                    <a:solidFill>
+                      <a:srgbClr val="FFFF00"/>
+                    </a:solidFill>
+                  </a:rPr>
                   <a:t>2</a:t>
                 </a:r>
               </a:p>
@@ -12815,7 +12895,11 @@
               <a:bodyPr wrap="none" anchor="ctr"/>
               <a:lstStyle/>
               <a:p>
-                <a:endParaRPr lang="nl-NL"/>
+                <a:endParaRPr lang="nl-NL">
+                  <a:solidFill>
+                    <a:srgbClr val="FFFF00"/>
+                  </a:solidFill>
+                </a:endParaRPr>
               </a:p>
             </p:txBody>
           </p:sp>
@@ -12836,7 +12920,7 @@
             <p:spPr bwMode="auto">
               <a:xfrm>
                 <a:off x="3915" y="2707"/>
-                <a:ext cx="196" cy="250"/>
+                <a:ext cx="197" cy="233"/>
               </a:xfrm>
               <a:prstGeom prst="rect">
                 <a:avLst/>
@@ -12856,7 +12940,11 @@
               <a:lstStyle/>
               <a:p>
                 <a:r>
-                  <a:rPr lang="en-US"/>
+                  <a:rPr lang="en-US">
+                    <a:solidFill>
+                      <a:srgbClr val="FFFF00"/>
+                    </a:solidFill>
+                  </a:rPr>
                   <a:t>0</a:t>
                 </a:r>
               </a:p>
@@ -13106,7 +13194,11 @@
               <a:bodyPr wrap="none" anchor="ctr"/>
               <a:lstStyle/>
               <a:p>
-                <a:endParaRPr lang="nl-NL"/>
+                <a:endParaRPr lang="nl-NL">
+                  <a:solidFill>
+                    <a:srgbClr val="FFFF00"/>
+                  </a:solidFill>
+                </a:endParaRPr>
               </a:p>
             </p:txBody>
           </p:sp>
@@ -13126,8 +13218,8 @@
             </p:nvSpPr>
             <p:spPr bwMode="auto">
               <a:xfrm>
-                <a:off x="4365" y="1769"/>
-                <a:ext cx="196" cy="250"/>
+                <a:off x="4364" y="1769"/>
+                <a:ext cx="197" cy="233"/>
               </a:xfrm>
               <a:prstGeom prst="rect">
                 <a:avLst/>
@@ -13148,7 +13240,11 @@
               <a:p>
                 <a:pPr algn="r"/>
                 <a:r>
-                  <a:rPr lang="en-US"/>
+                  <a:rPr lang="en-US" dirty="0">
+                    <a:solidFill>
+                      <a:srgbClr val="FFFF00"/>
+                    </a:solidFill>
+                  </a:rPr>
                   <a:t>0</a:t>
                 </a:r>
               </a:p>
@@ -13237,7 +13333,11 @@
                 <a:bodyPr wrap="none" anchor="ctr"/>
                 <a:lstStyle/>
                 <a:p>
-                  <a:endParaRPr lang="nl-NL"/>
+                  <a:endParaRPr lang="nl-NL">
+                    <a:solidFill>
+                      <a:srgbClr val="FFFF00"/>
+                    </a:solidFill>
+                  </a:endParaRPr>
                 </a:p>
               </p:txBody>
             </p:sp>
@@ -13258,7 +13358,7 @@
               <p:spPr bwMode="auto">
                 <a:xfrm>
                   <a:off x="4815" y="2707"/>
-                  <a:ext cx="196" cy="250"/>
+                  <a:ext cx="197" cy="233"/>
                 </a:xfrm>
                 <a:prstGeom prst="rect">
                   <a:avLst/>
@@ -13278,7 +13378,11 @@
                 <a:lstStyle/>
                 <a:p>
                   <a:r>
-                    <a:rPr lang="en-US"/>
+                    <a:rPr lang="en-US">
+                      <a:solidFill>
+                        <a:srgbClr val="FFFF00"/>
+                      </a:solidFill>
+                    </a:rPr>
                     <a:t>2</a:t>
                   </a:r>
                 </a:p>
@@ -13345,7 +13449,11 @@
                 <a:bodyPr wrap="none" anchor="ctr"/>
                 <a:lstStyle/>
                 <a:p>
-                  <a:endParaRPr lang="nl-NL"/>
+                  <a:endParaRPr lang="nl-NL">
+                    <a:solidFill>
+                      <a:srgbClr val="FFFF00"/>
+                    </a:solidFill>
+                  </a:endParaRPr>
                 </a:p>
               </p:txBody>
             </p:sp>
@@ -13366,7 +13474,7 @@
               <p:spPr bwMode="auto">
                 <a:xfrm>
                   <a:off x="3915" y="2707"/>
-                  <a:ext cx="196" cy="250"/>
+                  <a:ext cx="197" cy="233"/>
                 </a:xfrm>
                 <a:prstGeom prst="rect">
                   <a:avLst/>
@@ -13386,7 +13494,11 @@
                 <a:lstStyle/>
                 <a:p>
                   <a:r>
-                    <a:rPr lang="en-US"/>
+                    <a:rPr lang="en-US">
+                      <a:solidFill>
+                        <a:srgbClr val="FFFF00"/>
+                      </a:solidFill>
+                    </a:rPr>
                     <a:t>1</a:t>
                   </a:r>
                 </a:p>
@@ -13454,7 +13566,11 @@
               <a:bodyPr wrap="none" anchor="ctr"/>
               <a:lstStyle/>
               <a:p>
-                <a:endParaRPr lang="nl-NL"/>
+                <a:endParaRPr lang="nl-NL">
+                  <a:solidFill>
+                    <a:srgbClr val="FFFF00"/>
+                  </a:solidFill>
+                </a:endParaRPr>
               </a:p>
             </p:txBody>
           </p:sp>
@@ -13475,7 +13591,7 @@
             <p:spPr bwMode="auto">
               <a:xfrm>
                 <a:off x="4365" y="3645"/>
-                <a:ext cx="196" cy="250"/>
+                <a:ext cx="197" cy="233"/>
               </a:xfrm>
               <a:prstGeom prst="rect">
                 <a:avLst/>
@@ -13495,7 +13611,11 @@
               <a:lstStyle/>
               <a:p>
                 <a:r>
-                  <a:rPr lang="en-US"/>
+                  <a:rPr lang="en-US">
+                    <a:solidFill>
+                      <a:srgbClr val="FFFF00"/>
+                    </a:solidFill>
+                  </a:rPr>
                   <a:t>6</a:t>
                 </a:r>
               </a:p>
@@ -13538,7 +13658,11 @@
             <a:bodyPr/>
             <a:lstStyle/>
             <a:p>
-              <a:endParaRPr lang="en-US"/>
+              <a:endParaRPr lang="en-US">
+                <a:solidFill>
+                  <a:srgbClr val="FFFF00"/>
+                </a:solidFill>
+              </a:endParaRPr>
             </a:p>
           </p:txBody>
         </p:sp>
@@ -13578,7 +13702,11 @@
             <a:bodyPr/>
             <a:lstStyle/>
             <a:p>
-              <a:endParaRPr lang="en-US"/>
+              <a:endParaRPr lang="en-US">
+                <a:solidFill>
+                  <a:srgbClr val="FFFF00"/>
+                </a:solidFill>
+              </a:endParaRPr>
             </a:p>
           </p:txBody>
         </p:sp>
@@ -13642,7 +13770,11 @@
               <a:bodyPr wrap="none" anchor="ctr"/>
               <a:lstStyle/>
               <a:p>
-                <a:endParaRPr lang="nl-NL"/>
+                <a:endParaRPr lang="nl-NL">
+                  <a:solidFill>
+                    <a:srgbClr val="FFFF00"/>
+                  </a:solidFill>
+                </a:endParaRPr>
               </a:p>
             </p:txBody>
           </p:sp>
@@ -13662,8 +13794,8 @@
             </p:nvSpPr>
             <p:spPr bwMode="auto">
               <a:xfrm>
-                <a:off x="4365" y="1769"/>
-                <a:ext cx="196" cy="250"/>
+                <a:off x="4364" y="1769"/>
+                <a:ext cx="197" cy="233"/>
               </a:xfrm>
               <a:prstGeom prst="rect">
                 <a:avLst/>
@@ -13684,7 +13816,11 @@
               <a:p>
                 <a:pPr algn="r"/>
                 <a:r>
-                  <a:rPr lang="en-US"/>
+                  <a:rPr lang="en-US">
+                    <a:solidFill>
+                      <a:srgbClr val="FFFF00"/>
+                    </a:solidFill>
+                  </a:rPr>
                   <a:t>3</a:t>
                 </a:r>
               </a:p>
@@ -13773,7 +13909,11 @@
                 <a:bodyPr wrap="none" anchor="ctr"/>
                 <a:lstStyle/>
                 <a:p>
-                  <a:endParaRPr lang="nl-NL"/>
+                  <a:endParaRPr lang="nl-NL">
+                    <a:solidFill>
+                      <a:srgbClr val="FFFF00"/>
+                    </a:solidFill>
+                  </a:endParaRPr>
                 </a:p>
               </p:txBody>
             </p:sp>
@@ -13794,7 +13934,7 @@
               <p:spPr bwMode="auto">
                 <a:xfrm>
                   <a:off x="4815" y="2707"/>
-                  <a:ext cx="196" cy="250"/>
+                  <a:ext cx="197" cy="233"/>
                 </a:xfrm>
                 <a:prstGeom prst="rect">
                   <a:avLst/>
@@ -13814,7 +13954,11 @@
                 <a:lstStyle/>
                 <a:p>
                   <a:r>
-                    <a:rPr lang="en-US"/>
+                    <a:rPr lang="en-US">
+                      <a:solidFill>
+                        <a:srgbClr val="FFFF00"/>
+                      </a:solidFill>
+                    </a:rPr>
                     <a:t>5</a:t>
                   </a:r>
                 </a:p>
@@ -13881,7 +14025,11 @@
                 <a:bodyPr wrap="none" anchor="ctr"/>
                 <a:lstStyle/>
                 <a:p>
-                  <a:endParaRPr lang="nl-NL"/>
+                  <a:endParaRPr lang="nl-NL">
+                    <a:solidFill>
+                      <a:srgbClr val="FFFF00"/>
+                    </a:solidFill>
+                  </a:endParaRPr>
                 </a:p>
               </p:txBody>
             </p:sp>
@@ -13902,7 +14050,7 @@
               <p:spPr bwMode="auto">
                 <a:xfrm>
                   <a:off x="3915" y="2707"/>
-                  <a:ext cx="196" cy="250"/>
+                  <a:ext cx="197" cy="233"/>
                 </a:xfrm>
                 <a:prstGeom prst="rect">
                   <a:avLst/>
@@ -13922,7 +14070,11 @@
                 <a:lstStyle/>
                 <a:p>
                   <a:r>
-                    <a:rPr lang="en-US"/>
+                    <a:rPr lang="en-US">
+                      <a:solidFill>
+                        <a:srgbClr val="FFFF00"/>
+                      </a:solidFill>
+                    </a:rPr>
                     <a:t>4</a:t>
                   </a:r>
                 </a:p>
@@ -13966,7 +14118,11 @@
             <a:bodyPr/>
             <a:lstStyle/>
             <a:p>
-              <a:endParaRPr lang="en-US"/>
+              <a:endParaRPr lang="en-US">
+                <a:solidFill>
+                  <a:srgbClr val="FFFF00"/>
+                </a:solidFill>
+              </a:endParaRPr>
             </a:p>
           </p:txBody>
         </p:sp>
@@ -14006,7 +14162,11 @@
             <a:bodyPr/>
             <a:lstStyle/>
             <a:p>
-              <a:endParaRPr lang="en-US"/>
+              <a:endParaRPr lang="en-US">
+                <a:solidFill>
+                  <a:srgbClr val="FFFF00"/>
+                </a:solidFill>
+              </a:endParaRPr>
             </a:p>
           </p:txBody>
         </p:sp>
@@ -14046,7 +14206,11 @@
             <a:bodyPr/>
             <a:lstStyle/>
             <a:p>
-              <a:endParaRPr lang="en-US"/>
+              <a:endParaRPr lang="en-US">
+                <a:solidFill>
+                  <a:srgbClr val="FFFF00"/>
+                </a:solidFill>
+              </a:endParaRPr>
             </a:p>
           </p:txBody>
         </p:sp>
@@ -14086,7 +14250,11 @@
             <a:bodyPr/>
             <a:lstStyle/>
             <a:p>
-              <a:endParaRPr lang="en-US"/>
+              <a:endParaRPr lang="en-US">
+                <a:solidFill>
+                  <a:srgbClr val="FFFF00"/>
+                </a:solidFill>
+              </a:endParaRPr>
             </a:p>
           </p:txBody>
         </p:sp>
@@ -14126,7 +14294,11 @@
             <a:bodyPr/>
             <a:lstStyle/>
             <a:p>
-              <a:endParaRPr lang="en-US"/>
+              <a:endParaRPr lang="en-US">
+                <a:solidFill>
+                  <a:srgbClr val="FFFF00"/>
+                </a:solidFill>
+              </a:endParaRPr>
             </a:p>
           </p:txBody>
         </p:sp>
@@ -14166,7 +14338,11 @@
             <a:bodyPr/>
             <a:lstStyle/>
             <a:p>
-              <a:endParaRPr lang="en-US"/>
+              <a:endParaRPr lang="en-US">
+                <a:solidFill>
+                  <a:srgbClr val="FFFF00"/>
+                </a:solidFill>
+              </a:endParaRPr>
             </a:p>
           </p:txBody>
         </p:sp>
@@ -14206,7 +14382,11 @@
             <a:bodyPr/>
             <a:lstStyle/>
             <a:p>
-              <a:endParaRPr lang="en-US"/>
+              <a:endParaRPr lang="en-US">
+                <a:solidFill>
+                  <a:srgbClr val="FFFF00"/>
+                </a:solidFill>
+              </a:endParaRPr>
             </a:p>
           </p:txBody>
         </p:sp>
@@ -14656,7 +14836,11 @@
             <a:bodyPr wrap="none" anchor="ctr"/>
             <a:lstStyle/>
             <a:p>
-              <a:endParaRPr lang="nl-NL"/>
+              <a:endParaRPr lang="nl-NL">
+                <a:solidFill>
+                  <a:srgbClr val="FFFF00"/>
+                </a:solidFill>
+              </a:endParaRPr>
             </a:p>
           </p:txBody>
         </p:sp>
@@ -14670,8 +14854,8 @@
           </p:nvSpPr>
           <p:spPr bwMode="auto">
             <a:xfrm>
-              <a:off x="4365" y="1769"/>
-              <a:ext cx="196" cy="250"/>
+              <a:off x="4364" y="1769"/>
+              <a:ext cx="197" cy="233"/>
             </a:xfrm>
             <a:prstGeom prst="rect">
               <a:avLst/>
@@ -14692,7 +14876,11 @@
             <a:p>
               <a:pPr algn="r"/>
               <a:r>
-                <a:rPr lang="en-US"/>
+                <a:rPr lang="en-US">
+                  <a:solidFill>
+                    <a:srgbClr val="FFFF00"/>
+                  </a:solidFill>
+                </a:rPr>
                 <a:t>0</a:t>
               </a:r>
             </a:p>
@@ -14763,7 +14951,11 @@
               <a:bodyPr wrap="none" anchor="ctr"/>
               <a:lstStyle/>
               <a:p>
-                <a:endParaRPr lang="nl-NL"/>
+                <a:endParaRPr lang="nl-NL">
+                  <a:solidFill>
+                    <a:srgbClr val="FFFF00"/>
+                  </a:solidFill>
+                </a:endParaRPr>
               </a:p>
             </p:txBody>
           </p:sp>
@@ -14778,7 +14970,7 @@
             <p:spPr bwMode="auto">
               <a:xfrm>
                 <a:off x="4815" y="2707"/>
-                <a:ext cx="196" cy="250"/>
+                <a:ext cx="197" cy="233"/>
               </a:xfrm>
               <a:prstGeom prst="rect">
                 <a:avLst/>
@@ -14798,7 +14990,11 @@
               <a:lstStyle/>
               <a:p>
                 <a:r>
-                  <a:rPr lang="en-US"/>
+                  <a:rPr lang="en-US">
+                    <a:solidFill>
+                      <a:srgbClr val="FFFF00"/>
+                    </a:solidFill>
+                  </a:rPr>
                   <a:t>2</a:t>
                 </a:r>
               </a:p>
@@ -14853,7 +15049,11 @@
               <a:bodyPr wrap="none" anchor="ctr"/>
               <a:lstStyle/>
               <a:p>
-                <a:endParaRPr lang="nl-NL"/>
+                <a:endParaRPr lang="nl-NL">
+                  <a:solidFill>
+                    <a:srgbClr val="FFFF00"/>
+                  </a:solidFill>
+                </a:endParaRPr>
               </a:p>
             </p:txBody>
           </p:sp>
@@ -14868,7 +15068,7 @@
             <p:spPr bwMode="auto">
               <a:xfrm>
                 <a:off x="3915" y="2707"/>
-                <a:ext cx="196" cy="250"/>
+                <a:ext cx="197" cy="233"/>
               </a:xfrm>
               <a:prstGeom prst="rect">
                 <a:avLst/>
@@ -14888,7 +15088,11 @@
               <a:lstStyle/>
               <a:p>
                 <a:r>
-                  <a:rPr lang="en-US" dirty="0"/>
+                  <a:rPr lang="en-US" dirty="0">
+                    <a:solidFill>
+                      <a:srgbClr val="FFFF00"/>
+                    </a:solidFill>
+                  </a:rPr>
                   <a:t>1</a:t>
                 </a:r>
               </a:p>
@@ -14944,7 +15148,11 @@
             <a:bodyPr wrap="none" anchor="ctr"/>
             <a:lstStyle/>
             <a:p>
-              <a:endParaRPr lang="nl-NL"/>
+              <a:endParaRPr lang="nl-NL">
+                <a:solidFill>
+                  <a:srgbClr val="FFFF00"/>
+                </a:solidFill>
+              </a:endParaRPr>
             </a:p>
           </p:txBody>
         </p:sp>
@@ -14959,7 +15167,7 @@
           <p:spPr bwMode="auto">
             <a:xfrm>
               <a:off x="4556098" y="2238363"/>
-              <a:ext cx="311150" cy="396875"/>
+              <a:ext cx="312908" cy="369329"/>
             </a:xfrm>
             <a:prstGeom prst="rect">
               <a:avLst/>
@@ -14979,7 +15187,11 @@
             <a:lstStyle/>
             <a:p>
               <a:r>
-                <a:rPr lang="en-US" dirty="0"/>
+                <a:rPr lang="en-US" dirty="0">
+                  <a:solidFill>
+                    <a:srgbClr val="FFFF00"/>
+                  </a:solidFill>
+                </a:rPr>
                 <a:t>6</a:t>
               </a:r>
             </a:p>
@@ -15102,7 +15314,11 @@
             <a:bodyPr wrap="none" anchor="ctr"/>
             <a:lstStyle/>
             <a:p>
-              <a:endParaRPr lang="nl-NL"/>
+              <a:endParaRPr lang="nl-NL">
+                <a:solidFill>
+                  <a:srgbClr val="FFFF00"/>
+                </a:solidFill>
+              </a:endParaRPr>
             </a:p>
           </p:txBody>
         </p:sp>
@@ -15116,8 +15332,8 @@
           </p:nvSpPr>
           <p:spPr bwMode="auto">
             <a:xfrm>
-              <a:off x="4365" y="1769"/>
-              <a:ext cx="196" cy="250"/>
+              <a:off x="4364" y="1769"/>
+              <a:ext cx="197" cy="233"/>
             </a:xfrm>
             <a:prstGeom prst="rect">
               <a:avLst/>
@@ -15138,7 +15354,11 @@
             <a:p>
               <a:pPr algn="r"/>
               <a:r>
-                <a:rPr lang="en-US"/>
+                <a:rPr lang="en-US">
+                  <a:solidFill>
+                    <a:srgbClr val="FFFF00"/>
+                  </a:solidFill>
+                </a:rPr>
                 <a:t>3</a:t>
               </a:r>
             </a:p>
@@ -15209,7 +15429,11 @@
               <a:bodyPr wrap="none" anchor="ctr"/>
               <a:lstStyle/>
               <a:p>
-                <a:endParaRPr lang="nl-NL"/>
+                <a:endParaRPr lang="nl-NL">
+                  <a:solidFill>
+                    <a:srgbClr val="FFFF00"/>
+                  </a:solidFill>
+                </a:endParaRPr>
               </a:p>
             </p:txBody>
           </p:sp>
@@ -15224,7 +15448,7 @@
             <p:spPr bwMode="auto">
               <a:xfrm>
                 <a:off x="4815" y="2707"/>
-                <a:ext cx="196" cy="250"/>
+                <a:ext cx="197" cy="233"/>
               </a:xfrm>
               <a:prstGeom prst="rect">
                 <a:avLst/>
@@ -15244,7 +15468,11 @@
               <a:lstStyle/>
               <a:p>
                 <a:r>
-                  <a:rPr lang="en-US"/>
+                  <a:rPr lang="en-US">
+                    <a:solidFill>
+                      <a:srgbClr val="FFFF00"/>
+                    </a:solidFill>
+                  </a:rPr>
                   <a:t>5</a:t>
                 </a:r>
               </a:p>
@@ -15299,7 +15527,11 @@
               <a:bodyPr wrap="none" anchor="ctr"/>
               <a:lstStyle/>
               <a:p>
-                <a:endParaRPr lang="nl-NL"/>
+                <a:endParaRPr lang="nl-NL">
+                  <a:solidFill>
+                    <a:srgbClr val="FFFF00"/>
+                  </a:solidFill>
+                </a:endParaRPr>
               </a:p>
             </p:txBody>
           </p:sp>
@@ -15314,7 +15546,7 @@
             <p:spPr bwMode="auto">
               <a:xfrm>
                 <a:off x="3915" y="2707"/>
-                <a:ext cx="196" cy="250"/>
+                <a:ext cx="197" cy="233"/>
               </a:xfrm>
               <a:prstGeom prst="rect">
                 <a:avLst/>
@@ -15334,7 +15566,11 @@
               <a:lstStyle/>
               <a:p>
                 <a:r>
-                  <a:rPr lang="en-US"/>
+                  <a:rPr lang="en-US">
+                    <a:solidFill>
+                      <a:srgbClr val="FFFF00"/>
+                    </a:solidFill>
+                  </a:rPr>
                   <a:t>4</a:t>
                 </a:r>
               </a:p>
@@ -15725,7 +15961,11 @@
               <a:bodyPr wrap="none" anchor="ctr"/>
               <a:lstStyle/>
               <a:p>
-                <a:endParaRPr lang="nl-NL"/>
+                <a:endParaRPr lang="nl-NL">
+                  <a:solidFill>
+                    <a:srgbClr val="FFFF00"/>
+                  </a:solidFill>
+                </a:endParaRPr>
               </a:p>
             </p:txBody>
           </p:sp>
@@ -15760,7 +16000,11 @@
               <a:lstStyle/>
               <a:p>
                 <a:r>
-                  <a:rPr lang="en-US"/>
+                  <a:rPr lang="en-US">
+                    <a:solidFill>
+                      <a:srgbClr val="FFFF00"/>
+                    </a:solidFill>
+                  </a:rPr>
                   <a:t>7</a:t>
                 </a:r>
               </a:p>
@@ -15815,7 +16059,11 @@
               <a:bodyPr wrap="none" anchor="ctr"/>
               <a:lstStyle/>
               <a:p>
-                <a:endParaRPr lang="nl-NL"/>
+                <a:endParaRPr lang="nl-NL">
+                  <a:solidFill>
+                    <a:srgbClr val="FFFF00"/>
+                  </a:solidFill>
+                </a:endParaRPr>
               </a:p>
             </p:txBody>
           </p:sp>
@@ -15850,7 +16098,11 @@
               <a:lstStyle/>
               <a:p>
                 <a:r>
-                  <a:rPr lang="en-US"/>
+                  <a:rPr lang="en-US">
+                    <a:solidFill>
+                      <a:srgbClr val="FFFF00"/>
+                    </a:solidFill>
+                  </a:rPr>
                   <a:t>8</a:t>
                 </a:r>
               </a:p>
@@ -16874,7 +17126,11 @@
             <a:bodyPr wrap="none" anchor="ctr"/>
             <a:lstStyle/>
             <a:p>
-              <a:endParaRPr lang="nl-NL"/>
+              <a:endParaRPr lang="nl-NL">
+                <a:solidFill>
+                  <a:srgbClr val="FFFF00"/>
+                </a:solidFill>
+              </a:endParaRPr>
             </a:p>
           </p:txBody>
         </p:sp>
@@ -16894,8 +17150,8 @@
           </p:nvSpPr>
           <p:spPr bwMode="auto">
             <a:xfrm>
-              <a:off x="849" y="3244"/>
-              <a:ext cx="196" cy="250"/>
+              <a:off x="848" y="3244"/>
+              <a:ext cx="197" cy="233"/>
             </a:xfrm>
             <a:prstGeom prst="rect">
               <a:avLst/>
@@ -16916,7 +17172,11 @@
             <a:p>
               <a:pPr algn="r"/>
               <a:r>
-                <a:rPr lang="en-US"/>
+                <a:rPr lang="en-US">
+                  <a:solidFill>
+                    <a:srgbClr val="FFFF00"/>
+                  </a:solidFill>
+                </a:rPr>
                 <a:t>1</a:t>
               </a:r>
             </a:p>
@@ -16983,7 +17243,11 @@
             <a:bodyPr wrap="none" anchor="ctr"/>
             <a:lstStyle/>
             <a:p>
-              <a:endParaRPr lang="nl-NL"/>
+              <a:endParaRPr lang="nl-NL">
+                <a:solidFill>
+                  <a:srgbClr val="FFFF00"/>
+                </a:solidFill>
+              </a:endParaRPr>
             </a:p>
           </p:txBody>
         </p:sp>
@@ -17004,7 +17268,7 @@
           <p:spPr bwMode="auto">
             <a:xfrm>
               <a:off x="1374" y="3549"/>
-              <a:ext cx="196" cy="250"/>
+              <a:ext cx="197" cy="233"/>
             </a:xfrm>
             <a:prstGeom prst="rect">
               <a:avLst/>
@@ -17024,7 +17288,11 @@
             <a:lstStyle/>
             <a:p>
               <a:r>
-                <a:rPr lang="en-US"/>
+                <a:rPr lang="en-US">
+                  <a:solidFill>
+                    <a:srgbClr val="FFFF00"/>
+                  </a:solidFill>
+                </a:rPr>
                 <a:t>2</a:t>
               </a:r>
             </a:p>
@@ -17091,7 +17359,11 @@
             <a:bodyPr wrap="none" anchor="ctr"/>
             <a:lstStyle/>
             <a:p>
-              <a:endParaRPr lang="nl-NL"/>
+              <a:endParaRPr lang="nl-NL">
+                <a:solidFill>
+                  <a:srgbClr val="FFFF00"/>
+                </a:solidFill>
+              </a:endParaRPr>
             </a:p>
           </p:txBody>
         </p:sp>
@@ -17112,7 +17384,7 @@
           <p:spPr bwMode="auto">
             <a:xfrm>
               <a:off x="1404" y="2937"/>
-              <a:ext cx="196" cy="250"/>
+              <a:ext cx="197" cy="233"/>
             </a:xfrm>
             <a:prstGeom prst="rect">
               <a:avLst/>
@@ -17132,7 +17404,11 @@
             <a:lstStyle/>
             <a:p>
               <a:r>
-                <a:rPr lang="en-US"/>
+                <a:rPr lang="en-US">
+                  <a:solidFill>
+                    <a:srgbClr val="FFFF00"/>
+                  </a:solidFill>
+                </a:rPr>
                 <a:t>0</a:t>
               </a:r>
             </a:p>
@@ -17639,7 +17915,11 @@
             <a:bodyPr wrap="none" anchor="ctr"/>
             <a:lstStyle/>
             <a:p>
-              <a:endParaRPr lang="nl-NL"/>
+              <a:endParaRPr lang="nl-NL">
+                <a:solidFill>
+                  <a:srgbClr val="FFFF00"/>
+                </a:solidFill>
+              </a:endParaRPr>
             </a:p>
           </p:txBody>
         </p:sp>
@@ -17653,8 +17933,8 @@
           </p:nvSpPr>
           <p:spPr bwMode="auto">
             <a:xfrm>
-              <a:off x="849" y="3244"/>
-              <a:ext cx="196" cy="250"/>
+              <a:off x="848" y="3244"/>
+              <a:ext cx="197" cy="233"/>
             </a:xfrm>
             <a:prstGeom prst="rect">
               <a:avLst/>
@@ -17675,7 +17955,11 @@
             <a:p>
               <a:pPr algn="r"/>
               <a:r>
-                <a:rPr lang="en-US"/>
+                <a:rPr lang="en-US">
+                  <a:solidFill>
+                    <a:srgbClr val="FFFF00"/>
+                  </a:solidFill>
+                </a:rPr>
                 <a:t>1</a:t>
               </a:r>
             </a:p>
@@ -17730,7 +18014,11 @@
             <a:bodyPr wrap="none" anchor="ctr"/>
             <a:lstStyle/>
             <a:p>
-              <a:endParaRPr lang="nl-NL"/>
+              <a:endParaRPr lang="nl-NL">
+                <a:solidFill>
+                  <a:srgbClr val="FFFF00"/>
+                </a:solidFill>
+              </a:endParaRPr>
             </a:p>
           </p:txBody>
         </p:sp>
@@ -17745,7 +18033,7 @@
           <p:spPr bwMode="auto">
             <a:xfrm>
               <a:off x="1374" y="3549"/>
-              <a:ext cx="196" cy="250"/>
+              <a:ext cx="197" cy="233"/>
             </a:xfrm>
             <a:prstGeom prst="rect">
               <a:avLst/>
@@ -17765,7 +18053,11 @@
             <a:lstStyle/>
             <a:p>
               <a:r>
-                <a:rPr lang="en-US"/>
+                <a:rPr lang="en-US">
+                  <a:solidFill>
+                    <a:srgbClr val="FFFF00"/>
+                  </a:solidFill>
+                </a:rPr>
                 <a:t>2</a:t>
               </a:r>
             </a:p>
@@ -17820,7 +18112,11 @@
             <a:bodyPr wrap="none" anchor="ctr"/>
             <a:lstStyle/>
             <a:p>
-              <a:endParaRPr lang="nl-NL"/>
+              <a:endParaRPr lang="nl-NL">
+                <a:solidFill>
+                  <a:srgbClr val="FFFF00"/>
+                </a:solidFill>
+              </a:endParaRPr>
             </a:p>
           </p:txBody>
         </p:sp>
@@ -17835,7 +18131,7 @@
           <p:spPr bwMode="auto">
             <a:xfrm>
               <a:off x="1404" y="2937"/>
-              <a:ext cx="196" cy="250"/>
+              <a:ext cx="197" cy="233"/>
             </a:xfrm>
             <a:prstGeom prst="rect">
               <a:avLst/>
@@ -17855,7 +18151,11 @@
             <a:lstStyle/>
             <a:p>
               <a:r>
-                <a:rPr lang="en-US"/>
+                <a:rPr lang="en-US">
+                  <a:solidFill>
+                    <a:srgbClr val="FFFF00"/>
+                  </a:solidFill>
+                </a:rPr>
                 <a:t>0</a:t>
               </a:r>
             </a:p>
@@ -18633,7 +18933,11 @@
             <a:bodyPr wrap="none" anchor="ctr"/>
             <a:lstStyle/>
             <a:p>
-              <a:endParaRPr lang="nl-NL"/>
+              <a:endParaRPr lang="nl-NL">
+                <a:solidFill>
+                  <a:srgbClr val="FFFF00"/>
+                </a:solidFill>
+              </a:endParaRPr>
             </a:p>
           </p:txBody>
         </p:sp>
@@ -18648,7 +18952,7 @@
           <p:spPr bwMode="auto">
             <a:xfrm>
               <a:off x="3408354" y="5353067"/>
-              <a:ext cx="311150" cy="396875"/>
+              <a:ext cx="312909" cy="369335"/>
             </a:xfrm>
             <a:prstGeom prst="rect">
               <a:avLst/>
@@ -18668,7 +18972,11 @@
             <a:lstStyle/>
             <a:p>
               <a:r>
-                <a:rPr lang="en-US"/>
+                <a:rPr lang="en-US">
+                  <a:solidFill>
+                    <a:srgbClr val="FFFF00"/>
+                  </a:solidFill>
+                </a:rPr>
                 <a:t>2</a:t>
               </a:r>
             </a:p>
@@ -18722,7 +19030,11 @@
               <a:bodyPr wrap="none" anchor="ctr"/>
               <a:lstStyle/>
               <a:p>
-                <a:endParaRPr lang="nl-NL"/>
+                <a:endParaRPr lang="nl-NL">
+                  <a:solidFill>
+                    <a:srgbClr val="FFFF00"/>
+                  </a:solidFill>
+                </a:endParaRPr>
               </a:p>
             </p:txBody>
           </p:sp>
@@ -18737,7 +19049,7 @@
             <p:spPr bwMode="auto">
               <a:xfrm>
                 <a:off x="1404" y="2937"/>
-                <a:ext cx="196" cy="250"/>
+                <a:ext cx="197" cy="233"/>
               </a:xfrm>
               <a:prstGeom prst="rect">
                 <a:avLst/>
@@ -18757,7 +19069,11 @@
               <a:lstStyle/>
               <a:p>
                 <a:r>
-                  <a:rPr lang="en-US"/>
+                  <a:rPr lang="en-US">
+                    <a:solidFill>
+                      <a:srgbClr val="FFFF00"/>
+                    </a:solidFill>
+                  </a:rPr>
                   <a:t>0</a:t>
                 </a:r>
               </a:p>
@@ -18794,7 +19110,11 @@
             <a:bodyPr/>
             <a:lstStyle/>
             <a:p>
-              <a:endParaRPr lang="en-US"/>
+              <a:endParaRPr lang="en-US">
+                <a:solidFill>
+                  <a:srgbClr val="FFFF00"/>
+                </a:solidFill>
+              </a:endParaRPr>
             </a:p>
           </p:txBody>
         </p:sp>
@@ -18830,7 +19150,11 @@
             <a:bodyPr wrap="none" anchor="ctr"/>
             <a:lstStyle/>
             <a:p>
-              <a:endParaRPr lang="nl-NL"/>
+              <a:endParaRPr lang="nl-NL">
+                <a:solidFill>
+                  <a:srgbClr val="FFFF00"/>
+                </a:solidFill>
+              </a:endParaRPr>
             </a:p>
           </p:txBody>
         </p:sp>
@@ -18865,7 +19189,11 @@
             <a:lstStyle/>
             <a:p>
               <a:r>
-                <a:rPr lang="en-US"/>
+                <a:rPr lang="en-US">
+                  <a:solidFill>
+                    <a:srgbClr val="FFFF00"/>
+                  </a:solidFill>
+                </a:rPr>
                 <a:t>1</a:t>
               </a:r>
             </a:p>
@@ -19365,7 +19693,11 @@
             <a:bodyPr wrap="none" anchor="ctr"/>
             <a:lstStyle/>
             <a:p>
-              <a:endParaRPr lang="nl-NL"/>
+              <a:endParaRPr lang="nl-NL">
+                <a:solidFill>
+                  <a:srgbClr val="FFFF00"/>
+                </a:solidFill>
+              </a:endParaRPr>
             </a:p>
           </p:txBody>
         </p:sp>
@@ -19379,8 +19711,8 @@
           </p:nvSpPr>
           <p:spPr bwMode="auto">
             <a:xfrm>
-              <a:off x="4365" y="1769"/>
-              <a:ext cx="196" cy="250"/>
+              <a:off x="4364" y="1769"/>
+              <a:ext cx="197" cy="233"/>
             </a:xfrm>
             <a:prstGeom prst="rect">
               <a:avLst/>
@@ -19401,7 +19733,11 @@
             <a:p>
               <a:pPr algn="r"/>
               <a:r>
-                <a:rPr lang="en-US"/>
+                <a:rPr lang="en-US">
+                  <a:solidFill>
+                    <a:srgbClr val="FFFF00"/>
+                  </a:solidFill>
+                </a:rPr>
                 <a:t>0</a:t>
               </a:r>
             </a:p>
@@ -19456,7 +19792,11 @@
             <a:bodyPr wrap="none" anchor="ctr"/>
             <a:lstStyle/>
             <a:p>
-              <a:endParaRPr lang="nl-NL"/>
+              <a:endParaRPr lang="nl-NL">
+                <a:solidFill>
+                  <a:srgbClr val="FFFF00"/>
+                </a:solidFill>
+              </a:endParaRPr>
             </a:p>
           </p:txBody>
         </p:sp>
@@ -19471,7 +19811,7 @@
           <p:spPr bwMode="auto">
             <a:xfrm>
               <a:off x="4815" y="2707"/>
-              <a:ext cx="196" cy="250"/>
+              <a:ext cx="197" cy="233"/>
             </a:xfrm>
             <a:prstGeom prst="rect">
               <a:avLst/>
@@ -19491,7 +19831,11 @@
             <a:lstStyle/>
             <a:p>
               <a:r>
-                <a:rPr lang="en-US"/>
+                <a:rPr lang="en-US">
+                  <a:solidFill>
+                    <a:srgbClr val="FFFF00"/>
+                  </a:solidFill>
+                </a:rPr>
                 <a:t>2</a:t>
               </a:r>
             </a:p>
@@ -19546,7 +19890,11 @@
             <a:bodyPr wrap="none" anchor="ctr"/>
             <a:lstStyle/>
             <a:p>
-              <a:endParaRPr lang="nl-NL"/>
+              <a:endParaRPr lang="nl-NL">
+                <a:solidFill>
+                  <a:srgbClr val="FFFF00"/>
+                </a:solidFill>
+              </a:endParaRPr>
             </a:p>
           </p:txBody>
         </p:sp>
@@ -19561,7 +19909,7 @@
           <p:spPr bwMode="auto">
             <a:xfrm>
               <a:off x="3915" y="2707"/>
-              <a:ext cx="196" cy="250"/>
+              <a:ext cx="197" cy="233"/>
             </a:xfrm>
             <a:prstGeom prst="rect">
               <a:avLst/>
@@ -19581,7 +19929,11 @@
             <a:lstStyle/>
             <a:p>
               <a:r>
-                <a:rPr lang="en-US"/>
+                <a:rPr lang="en-US">
+                  <a:solidFill>
+                    <a:srgbClr val="FFFF00"/>
+                  </a:solidFill>
+                </a:rPr>
                 <a:t>1</a:t>
               </a:r>
             </a:p>
@@ -19704,7 +20056,11 @@
             <a:bodyPr wrap="none" anchor="ctr"/>
             <a:lstStyle/>
             <a:p>
-              <a:endParaRPr lang="nl-NL"/>
+              <a:endParaRPr lang="nl-NL">
+                <a:solidFill>
+                  <a:srgbClr val="FFFF00"/>
+                </a:solidFill>
+              </a:endParaRPr>
             </a:p>
           </p:txBody>
         </p:sp>
@@ -19718,8 +20074,8 @@
           </p:nvSpPr>
           <p:spPr bwMode="auto">
             <a:xfrm>
-              <a:off x="4365" y="1769"/>
-              <a:ext cx="196" cy="250"/>
+              <a:off x="4364" y="1769"/>
+              <a:ext cx="197" cy="233"/>
             </a:xfrm>
             <a:prstGeom prst="rect">
               <a:avLst/>
@@ -19740,7 +20096,11 @@
             <a:p>
               <a:pPr algn="r"/>
               <a:r>
-                <a:rPr lang="en-US"/>
+                <a:rPr lang="en-US">
+                  <a:solidFill>
+                    <a:srgbClr val="FFFF00"/>
+                  </a:solidFill>
+                </a:rPr>
                 <a:t>3</a:t>
               </a:r>
             </a:p>
@@ -20093,7 +20453,11 @@
             <a:bodyPr wrap="none" anchor="ctr"/>
             <a:lstStyle/>
             <a:p>
-              <a:endParaRPr lang="nl-NL"/>
+              <a:endParaRPr lang="nl-NL">
+                <a:solidFill>
+                  <a:srgbClr val="FFFF00"/>
+                </a:solidFill>
+              </a:endParaRPr>
             </a:p>
           </p:txBody>
         </p:sp>
@@ -20108,7 +20472,7 @@
           <p:spPr bwMode="auto">
             <a:xfrm>
               <a:off x="4365" y="3645"/>
-              <a:ext cx="196" cy="250"/>
+              <a:ext cx="197" cy="233"/>
             </a:xfrm>
             <a:prstGeom prst="rect">
               <a:avLst/>
@@ -20128,7 +20492,11 @@
             <a:lstStyle/>
             <a:p>
               <a:r>
-                <a:rPr lang="en-US"/>
+                <a:rPr lang="en-US">
+                  <a:solidFill>
+                    <a:srgbClr val="FFFF00"/>
+                  </a:solidFill>
+                </a:rPr>
                 <a:t>6</a:t>
               </a:r>
             </a:p>
@@ -20837,7 +21205,11 @@
               <a:bodyPr wrap="none" anchor="ctr"/>
               <a:lstStyle/>
               <a:p>
-                <a:endParaRPr lang="nl-NL"/>
+                <a:endParaRPr lang="nl-NL">
+                  <a:solidFill>
+                    <a:srgbClr val="FFFF00"/>
+                  </a:solidFill>
+                </a:endParaRPr>
               </a:p>
             </p:txBody>
           </p:sp>
@@ -20852,7 +21224,7 @@
             <p:spPr bwMode="auto">
               <a:xfrm>
                 <a:off x="761" y="3397"/>
-                <a:ext cx="196" cy="250"/>
+                <a:ext cx="197" cy="233"/>
               </a:xfrm>
               <a:prstGeom prst="rect">
                 <a:avLst/>
@@ -20872,7 +21244,11 @@
               <a:lstStyle/>
               <a:p>
                 <a:r>
-                  <a:rPr lang="en-US"/>
+                  <a:rPr lang="en-US">
+                    <a:solidFill>
+                      <a:srgbClr val="FFFF00"/>
+                    </a:solidFill>
+                  </a:rPr>
                   <a:t>5</a:t>
                 </a:r>
               </a:p>
@@ -20927,7 +21303,11 @@
               <a:bodyPr wrap="none" anchor="ctr"/>
               <a:lstStyle/>
               <a:p>
-                <a:endParaRPr lang="nl-NL"/>
+                <a:endParaRPr lang="nl-NL">
+                  <a:solidFill>
+                    <a:srgbClr val="FFFF00"/>
+                  </a:solidFill>
+                </a:endParaRPr>
               </a:p>
             </p:txBody>
           </p:sp>
@@ -20941,8 +21321,8 @@
             </p:nvSpPr>
             <p:spPr bwMode="auto">
               <a:xfrm>
-                <a:off x="4365" y="1769"/>
-                <a:ext cx="196" cy="250"/>
+                <a:off x="4364" y="1769"/>
+                <a:ext cx="197" cy="233"/>
               </a:xfrm>
               <a:prstGeom prst="rect">
                 <a:avLst/>
@@ -20963,7 +21343,11 @@
               <a:p>
                 <a:pPr algn="r"/>
                 <a:r>
-                  <a:rPr lang="en-US"/>
+                  <a:rPr lang="en-US">
+                    <a:solidFill>
+                      <a:srgbClr val="FFFF00"/>
+                    </a:solidFill>
+                  </a:rPr>
                   <a:t>0</a:t>
                 </a:r>
               </a:p>
@@ -21018,7 +21402,11 @@
               <a:bodyPr wrap="none" anchor="ctr"/>
               <a:lstStyle/>
               <a:p>
-                <a:endParaRPr lang="nl-NL"/>
+                <a:endParaRPr lang="nl-NL">
+                  <a:solidFill>
+                    <a:srgbClr val="FFFF00"/>
+                  </a:solidFill>
+                </a:endParaRPr>
               </a:p>
             </p:txBody>
           </p:sp>
@@ -21033,7 +21421,7 @@
             <p:spPr bwMode="auto">
               <a:xfrm>
                 <a:off x="4815" y="2707"/>
-                <a:ext cx="196" cy="250"/>
+                <a:ext cx="197" cy="233"/>
               </a:xfrm>
               <a:prstGeom prst="rect">
                 <a:avLst/>
@@ -21053,7 +21441,11 @@
               <a:lstStyle/>
               <a:p>
                 <a:r>
-                  <a:rPr lang="en-US"/>
+                  <a:rPr lang="en-US">
+                    <a:solidFill>
+                      <a:srgbClr val="FFFF00"/>
+                    </a:solidFill>
+                  </a:rPr>
                   <a:t>2</a:t>
                 </a:r>
               </a:p>
@@ -21108,7 +21500,11 @@
               <a:bodyPr wrap="none" anchor="ctr"/>
               <a:lstStyle/>
               <a:p>
-                <a:endParaRPr lang="nl-NL"/>
+                <a:endParaRPr lang="nl-NL">
+                  <a:solidFill>
+                    <a:srgbClr val="FFFF00"/>
+                  </a:solidFill>
+                </a:endParaRPr>
               </a:p>
             </p:txBody>
           </p:sp>
@@ -21123,7 +21519,7 @@
             <p:spPr bwMode="auto">
               <a:xfrm>
                 <a:off x="3915" y="2707"/>
-                <a:ext cx="196" cy="250"/>
+                <a:ext cx="197" cy="233"/>
               </a:xfrm>
               <a:prstGeom prst="rect">
                 <a:avLst/>
@@ -21143,7 +21539,11 @@
               <a:lstStyle/>
               <a:p>
                 <a:r>
-                  <a:rPr lang="en-US"/>
+                  <a:rPr lang="en-US">
+                    <a:solidFill>
+                      <a:srgbClr val="FFFF00"/>
+                    </a:solidFill>
+                  </a:rPr>
                   <a:t>1</a:t>
                 </a:r>
               </a:p>
@@ -21180,7 +21580,11 @@
             <a:bodyPr/>
             <a:lstStyle/>
             <a:p>
-              <a:endParaRPr lang="en-US"/>
+              <a:endParaRPr lang="en-US">
+                <a:solidFill>
+                  <a:srgbClr val="FFFF00"/>
+                </a:solidFill>
+              </a:endParaRPr>
             </a:p>
           </p:txBody>
         </p:sp>
@@ -21214,7 +21618,11 @@
             <a:bodyPr/>
             <a:lstStyle/>
             <a:p>
-              <a:endParaRPr lang="en-US"/>
+              <a:endParaRPr lang="en-US">
+                <a:solidFill>
+                  <a:srgbClr val="FFFF00"/>
+                </a:solidFill>
+              </a:endParaRPr>
             </a:p>
           </p:txBody>
         </p:sp>
@@ -21266,7 +21674,11 @@
               <a:bodyPr wrap="none" anchor="ctr"/>
               <a:lstStyle/>
               <a:p>
-                <a:endParaRPr lang="nl-NL"/>
+                <a:endParaRPr lang="nl-NL">
+                  <a:solidFill>
+                    <a:srgbClr val="FFFF00"/>
+                  </a:solidFill>
+                </a:endParaRPr>
               </a:p>
             </p:txBody>
           </p:sp>
@@ -21280,8 +21692,8 @@
             </p:nvSpPr>
             <p:spPr bwMode="auto">
               <a:xfrm>
-                <a:off x="4365" y="1769"/>
-                <a:ext cx="196" cy="250"/>
+                <a:off x="4364" y="1769"/>
+                <a:ext cx="197" cy="233"/>
               </a:xfrm>
               <a:prstGeom prst="rect">
                 <a:avLst/>
@@ -21302,7 +21714,11 @@
               <a:p>
                 <a:pPr algn="r"/>
                 <a:r>
-                  <a:rPr lang="en-US"/>
+                  <a:rPr lang="en-US">
+                    <a:solidFill>
+                      <a:srgbClr val="FFFF00"/>
+                    </a:solidFill>
+                  </a:rPr>
                   <a:t>3</a:t>
                 </a:r>
               </a:p>
@@ -21357,7 +21773,11 @@
               <a:bodyPr wrap="none" anchor="ctr"/>
               <a:lstStyle/>
               <a:p>
-                <a:endParaRPr lang="nl-NL"/>
+                <a:endParaRPr lang="nl-NL">
+                  <a:solidFill>
+                    <a:srgbClr val="FFFF00"/>
+                  </a:solidFill>
+                </a:endParaRPr>
               </a:p>
             </p:txBody>
           </p:sp>
@@ -21372,7 +21792,7 @@
             <p:spPr bwMode="auto">
               <a:xfrm>
                 <a:off x="3915" y="2707"/>
-                <a:ext cx="196" cy="250"/>
+                <a:ext cx="197" cy="233"/>
               </a:xfrm>
               <a:prstGeom prst="rect">
                 <a:avLst/>
@@ -21392,7 +21812,11 @@
               <a:lstStyle/>
               <a:p>
                 <a:r>
-                  <a:rPr lang="en-US"/>
+                  <a:rPr lang="en-US">
+                    <a:solidFill>
+                      <a:srgbClr val="FFFF00"/>
+                    </a:solidFill>
+                  </a:rPr>
                   <a:t>4</a:t>
                 </a:r>
               </a:p>
@@ -21429,7 +21853,11 @@
             <a:bodyPr/>
             <a:lstStyle/>
             <a:p>
-              <a:endParaRPr lang="en-US"/>
+              <a:endParaRPr lang="en-US">
+                <a:solidFill>
+                  <a:srgbClr val="FFFF00"/>
+                </a:solidFill>
+              </a:endParaRPr>
             </a:p>
           </p:txBody>
         </p:sp>
@@ -21463,7 +21891,11 @@
             <a:bodyPr/>
             <a:lstStyle/>
             <a:p>
-              <a:endParaRPr lang="en-US"/>
+              <a:endParaRPr lang="en-US">
+                <a:solidFill>
+                  <a:srgbClr val="FFFF00"/>
+                </a:solidFill>
+              </a:endParaRPr>
             </a:p>
           </p:txBody>
         </p:sp>
@@ -21497,7 +21929,11 @@
             <a:bodyPr/>
             <a:lstStyle/>
             <a:p>
-              <a:endParaRPr lang="en-US"/>
+              <a:endParaRPr lang="en-US">
+                <a:solidFill>
+                  <a:srgbClr val="FFFF00"/>
+                </a:solidFill>
+              </a:endParaRPr>
             </a:p>
           </p:txBody>
         </p:sp>
@@ -21531,7 +21967,11 @@
             <a:bodyPr/>
             <a:lstStyle/>
             <a:p>
-              <a:endParaRPr lang="en-US"/>
+              <a:endParaRPr lang="en-US">
+                <a:solidFill>
+                  <a:srgbClr val="FFFF00"/>
+                </a:solidFill>
+              </a:endParaRPr>
             </a:p>
           </p:txBody>
         </p:sp>
@@ -21565,7 +22005,11 @@
             <a:bodyPr/>
             <a:lstStyle/>
             <a:p>
-              <a:endParaRPr lang="en-US"/>
+              <a:endParaRPr lang="en-US">
+                <a:solidFill>
+                  <a:srgbClr val="FFFF00"/>
+                </a:solidFill>
+              </a:endParaRPr>
             </a:p>
           </p:txBody>
         </p:sp>
@@ -21599,7 +22043,11 @@
             <a:bodyPr/>
             <a:lstStyle/>
             <a:p>
-              <a:endParaRPr lang="en-US"/>
+              <a:endParaRPr lang="en-US">
+                <a:solidFill>
+                  <a:srgbClr val="FFFF00"/>
+                </a:solidFill>
+              </a:endParaRPr>
             </a:p>
           </p:txBody>
         </p:sp>
@@ -21633,7 +22081,11 @@
             <a:bodyPr/>
             <a:lstStyle/>
             <a:p>
-              <a:endParaRPr lang="en-US"/>
+              <a:endParaRPr lang="en-US">
+                <a:solidFill>
+                  <a:srgbClr val="FFFF00"/>
+                </a:solidFill>
+              </a:endParaRPr>
             </a:p>
           </p:txBody>
         </p:sp>
@@ -21685,7 +22137,11 @@
               <a:bodyPr wrap="none" anchor="ctr"/>
               <a:lstStyle/>
               <a:p>
-                <a:endParaRPr lang="nl-NL"/>
+                <a:endParaRPr lang="nl-NL">
+                  <a:solidFill>
+                    <a:srgbClr val="FFFF00"/>
+                  </a:solidFill>
+                </a:endParaRPr>
               </a:p>
             </p:txBody>
           </p:sp>
@@ -21700,7 +22156,7 @@
             <p:spPr bwMode="auto">
               <a:xfrm>
                 <a:off x="4365" y="3645"/>
-                <a:ext cx="196" cy="250"/>
+                <a:ext cx="197" cy="233"/>
               </a:xfrm>
               <a:prstGeom prst="rect">
                 <a:avLst/>
@@ -21720,7 +22176,11 @@
               <a:lstStyle/>
               <a:p>
                 <a:r>
-                  <a:rPr lang="en-US"/>
+                  <a:rPr lang="en-US">
+                    <a:solidFill>
+                      <a:srgbClr val="FFFF00"/>
+                    </a:solidFill>
+                  </a:rPr>
                   <a:t>6</a:t>
                 </a:r>
               </a:p>
@@ -21757,7 +22217,11 @@
             <a:bodyPr/>
             <a:lstStyle/>
             <a:p>
-              <a:endParaRPr lang="en-US"/>
+              <a:endParaRPr lang="en-US">
+                <a:solidFill>
+                  <a:srgbClr val="FFFF00"/>
+                </a:solidFill>
+              </a:endParaRPr>
             </a:p>
           </p:txBody>
         </p:sp>
@@ -23037,7 +23501,11 @@
               <a:bodyPr wrap="none" anchor="ctr"/>
               <a:lstStyle/>
               <a:p>
-                <a:endParaRPr lang="nl-NL"/>
+                <a:endParaRPr lang="nl-NL">
+                  <a:solidFill>
+                    <a:srgbClr val="FFFF00"/>
+                  </a:solidFill>
+                </a:endParaRPr>
               </a:p>
             </p:txBody>
           </p:sp>
@@ -23052,7 +23520,7 @@
             <p:spPr bwMode="auto">
               <a:xfrm>
                 <a:off x="761" y="3397"/>
-                <a:ext cx="196" cy="250"/>
+                <a:ext cx="197" cy="233"/>
               </a:xfrm>
               <a:prstGeom prst="rect">
                 <a:avLst/>
@@ -23072,7 +23540,11 @@
               <a:lstStyle/>
               <a:p>
                 <a:r>
-                  <a:rPr lang="en-US"/>
+                  <a:rPr lang="en-US">
+                    <a:solidFill>
+                      <a:srgbClr val="FFFF00"/>
+                    </a:solidFill>
+                  </a:rPr>
                   <a:t>5</a:t>
                 </a:r>
               </a:p>
@@ -23127,7 +23599,11 @@
               <a:bodyPr wrap="none" anchor="ctr"/>
               <a:lstStyle/>
               <a:p>
-                <a:endParaRPr lang="nl-NL"/>
+                <a:endParaRPr lang="nl-NL">
+                  <a:solidFill>
+                    <a:srgbClr val="FFFF00"/>
+                  </a:solidFill>
+                </a:endParaRPr>
               </a:p>
             </p:txBody>
           </p:sp>
@@ -23141,8 +23617,8 @@
             </p:nvSpPr>
             <p:spPr bwMode="auto">
               <a:xfrm>
-                <a:off x="4365" y="1769"/>
-                <a:ext cx="196" cy="250"/>
+                <a:off x="4364" y="1769"/>
+                <a:ext cx="197" cy="233"/>
               </a:xfrm>
               <a:prstGeom prst="rect">
                 <a:avLst/>
@@ -23163,7 +23639,11 @@
               <a:p>
                 <a:pPr algn="r"/>
                 <a:r>
-                  <a:rPr lang="en-US"/>
+                  <a:rPr lang="en-US">
+                    <a:solidFill>
+                      <a:srgbClr val="FFFF00"/>
+                    </a:solidFill>
+                  </a:rPr>
                   <a:t>0</a:t>
                 </a:r>
               </a:p>
@@ -23218,7 +23698,11 @@
               <a:bodyPr wrap="none" anchor="ctr"/>
               <a:lstStyle/>
               <a:p>
-                <a:endParaRPr lang="nl-NL"/>
+                <a:endParaRPr lang="nl-NL">
+                  <a:solidFill>
+                    <a:srgbClr val="FFFF00"/>
+                  </a:solidFill>
+                </a:endParaRPr>
               </a:p>
             </p:txBody>
           </p:sp>
@@ -23233,7 +23717,7 @@
             <p:spPr bwMode="auto">
               <a:xfrm>
                 <a:off x="4815" y="2707"/>
-                <a:ext cx="196" cy="250"/>
+                <a:ext cx="197" cy="233"/>
               </a:xfrm>
               <a:prstGeom prst="rect">
                 <a:avLst/>
@@ -23253,7 +23737,11 @@
               <a:lstStyle/>
               <a:p>
                 <a:r>
-                  <a:rPr lang="en-US"/>
+                  <a:rPr lang="en-US">
+                    <a:solidFill>
+                      <a:srgbClr val="FFFF00"/>
+                    </a:solidFill>
+                  </a:rPr>
                   <a:t>2</a:t>
                 </a:r>
               </a:p>
@@ -23308,7 +23796,11 @@
               <a:bodyPr wrap="none" anchor="ctr"/>
               <a:lstStyle/>
               <a:p>
-                <a:endParaRPr lang="nl-NL"/>
+                <a:endParaRPr lang="nl-NL">
+                  <a:solidFill>
+                    <a:srgbClr val="FFFF00"/>
+                  </a:solidFill>
+                </a:endParaRPr>
               </a:p>
             </p:txBody>
           </p:sp>
@@ -23323,7 +23815,7 @@
             <p:spPr bwMode="auto">
               <a:xfrm>
                 <a:off x="3915" y="2707"/>
-                <a:ext cx="196" cy="250"/>
+                <a:ext cx="197" cy="233"/>
               </a:xfrm>
               <a:prstGeom prst="rect">
                 <a:avLst/>
@@ -23343,7 +23835,11 @@
               <a:lstStyle/>
               <a:p>
                 <a:r>
-                  <a:rPr lang="en-US"/>
+                  <a:rPr lang="en-US">
+                    <a:solidFill>
+                      <a:srgbClr val="FFFF00"/>
+                    </a:solidFill>
+                  </a:rPr>
                   <a:t>1</a:t>
                 </a:r>
               </a:p>
@@ -23380,7 +23876,11 @@
             <a:bodyPr/>
             <a:lstStyle/>
             <a:p>
-              <a:endParaRPr lang="en-US"/>
+              <a:endParaRPr lang="en-US">
+                <a:solidFill>
+                  <a:srgbClr val="FFFF00"/>
+                </a:solidFill>
+              </a:endParaRPr>
             </a:p>
           </p:txBody>
         </p:sp>
@@ -23414,7 +23914,11 @@
             <a:bodyPr/>
             <a:lstStyle/>
             <a:p>
-              <a:endParaRPr lang="en-US"/>
+              <a:endParaRPr lang="en-US">
+                <a:solidFill>
+                  <a:srgbClr val="FFFF00"/>
+                </a:solidFill>
+              </a:endParaRPr>
             </a:p>
           </p:txBody>
         </p:sp>
@@ -23466,7 +23970,11 @@
               <a:bodyPr wrap="none" anchor="ctr"/>
               <a:lstStyle/>
               <a:p>
-                <a:endParaRPr lang="nl-NL"/>
+                <a:endParaRPr lang="nl-NL">
+                  <a:solidFill>
+                    <a:srgbClr val="FFFF00"/>
+                  </a:solidFill>
+                </a:endParaRPr>
               </a:p>
             </p:txBody>
           </p:sp>
@@ -23480,8 +23988,8 @@
             </p:nvSpPr>
             <p:spPr bwMode="auto">
               <a:xfrm>
-                <a:off x="4365" y="1769"/>
-                <a:ext cx="196" cy="250"/>
+                <a:off x="4364" y="1769"/>
+                <a:ext cx="197" cy="233"/>
               </a:xfrm>
               <a:prstGeom prst="rect">
                 <a:avLst/>
@@ -23502,7 +24010,11 @@
               <a:p>
                 <a:pPr algn="r"/>
                 <a:r>
-                  <a:rPr lang="en-US"/>
+                  <a:rPr lang="en-US">
+                    <a:solidFill>
+                      <a:srgbClr val="FFFF00"/>
+                    </a:solidFill>
+                  </a:rPr>
                   <a:t>3</a:t>
                 </a:r>
               </a:p>
@@ -23557,7 +24069,11 @@
               <a:bodyPr wrap="none" anchor="ctr"/>
               <a:lstStyle/>
               <a:p>
-                <a:endParaRPr lang="nl-NL"/>
+                <a:endParaRPr lang="nl-NL">
+                  <a:solidFill>
+                    <a:srgbClr val="FFFF00"/>
+                  </a:solidFill>
+                </a:endParaRPr>
               </a:p>
             </p:txBody>
           </p:sp>
@@ -23572,7 +24088,7 @@
             <p:spPr bwMode="auto">
               <a:xfrm>
                 <a:off x="3915" y="2707"/>
-                <a:ext cx="196" cy="250"/>
+                <a:ext cx="197" cy="233"/>
               </a:xfrm>
               <a:prstGeom prst="rect">
                 <a:avLst/>
@@ -23592,7 +24108,11 @@
               <a:lstStyle/>
               <a:p>
                 <a:r>
-                  <a:rPr lang="en-US"/>
+                  <a:rPr lang="en-US">
+                    <a:solidFill>
+                      <a:srgbClr val="FFFF00"/>
+                    </a:solidFill>
+                  </a:rPr>
                   <a:t>4</a:t>
                 </a:r>
               </a:p>
@@ -23629,7 +24149,11 @@
             <a:bodyPr/>
             <a:lstStyle/>
             <a:p>
-              <a:endParaRPr lang="en-US"/>
+              <a:endParaRPr lang="en-US">
+                <a:solidFill>
+                  <a:srgbClr val="FFFF00"/>
+                </a:solidFill>
+              </a:endParaRPr>
             </a:p>
           </p:txBody>
         </p:sp>
@@ -23663,7 +24187,11 @@
             <a:bodyPr/>
             <a:lstStyle/>
             <a:p>
-              <a:endParaRPr lang="en-US"/>
+              <a:endParaRPr lang="en-US">
+                <a:solidFill>
+                  <a:srgbClr val="FFFF00"/>
+                </a:solidFill>
+              </a:endParaRPr>
             </a:p>
           </p:txBody>
         </p:sp>
@@ -23697,7 +24225,11 @@
             <a:bodyPr/>
             <a:lstStyle/>
             <a:p>
-              <a:endParaRPr lang="en-US"/>
+              <a:endParaRPr lang="en-US">
+                <a:solidFill>
+                  <a:srgbClr val="FFFF00"/>
+                </a:solidFill>
+              </a:endParaRPr>
             </a:p>
           </p:txBody>
         </p:sp>
@@ -23731,7 +24263,11 @@
             <a:bodyPr/>
             <a:lstStyle/>
             <a:p>
-              <a:endParaRPr lang="en-US"/>
+              <a:endParaRPr lang="en-US">
+                <a:solidFill>
+                  <a:srgbClr val="FFFF00"/>
+                </a:solidFill>
+              </a:endParaRPr>
             </a:p>
           </p:txBody>
         </p:sp>
@@ -23765,7 +24301,11 @@
             <a:bodyPr/>
             <a:lstStyle/>
             <a:p>
-              <a:endParaRPr lang="en-US"/>
+              <a:endParaRPr lang="en-US">
+                <a:solidFill>
+                  <a:srgbClr val="FFFF00"/>
+                </a:solidFill>
+              </a:endParaRPr>
             </a:p>
           </p:txBody>
         </p:sp>
@@ -23799,7 +24339,11 @@
             <a:bodyPr/>
             <a:lstStyle/>
             <a:p>
-              <a:endParaRPr lang="en-US"/>
+              <a:endParaRPr lang="en-US">
+                <a:solidFill>
+                  <a:srgbClr val="FFFF00"/>
+                </a:solidFill>
+              </a:endParaRPr>
             </a:p>
           </p:txBody>
         </p:sp>
@@ -23833,7 +24377,11 @@
             <a:bodyPr/>
             <a:lstStyle/>
             <a:p>
-              <a:endParaRPr lang="en-US"/>
+              <a:endParaRPr lang="en-US">
+                <a:solidFill>
+                  <a:srgbClr val="FFFF00"/>
+                </a:solidFill>
+              </a:endParaRPr>
             </a:p>
           </p:txBody>
         </p:sp>
@@ -23885,7 +24433,11 @@
               <a:bodyPr wrap="none" anchor="ctr"/>
               <a:lstStyle/>
               <a:p>
-                <a:endParaRPr lang="nl-NL"/>
+                <a:endParaRPr lang="nl-NL">
+                  <a:solidFill>
+                    <a:srgbClr val="FFFF00"/>
+                  </a:solidFill>
+                </a:endParaRPr>
               </a:p>
             </p:txBody>
           </p:sp>
@@ -23900,7 +24452,7 @@
             <p:spPr bwMode="auto">
               <a:xfrm>
                 <a:off x="4365" y="3645"/>
-                <a:ext cx="196" cy="250"/>
+                <a:ext cx="197" cy="233"/>
               </a:xfrm>
               <a:prstGeom prst="rect">
                 <a:avLst/>
@@ -23920,7 +24472,11 @@
               <a:lstStyle/>
               <a:p>
                 <a:r>
-                  <a:rPr lang="en-US"/>
+                  <a:rPr lang="en-US">
+                    <a:solidFill>
+                      <a:srgbClr val="FFFF00"/>
+                    </a:solidFill>
+                  </a:rPr>
                   <a:t>6</a:t>
                 </a:r>
               </a:p>
@@ -23957,7 +24513,11 @@
             <a:bodyPr/>
             <a:lstStyle/>
             <a:p>
-              <a:endParaRPr lang="en-US"/>
+              <a:endParaRPr lang="en-US">
+                <a:solidFill>
+                  <a:srgbClr val="FFFF00"/>
+                </a:solidFill>
+              </a:endParaRPr>
             </a:p>
           </p:txBody>
         </p:sp>
@@ -26983,7 +27543,7 @@
           <p:nvPr>
             <p:extLst>
               <p:ext uri="{D42A27DB-BD31-4B8C-83A1-F6EECF244321}">
-                <p14:modId xmlns:p14="http://schemas.microsoft.com/office/powerpoint/2010/main" val="1511201008"/>
+                <p14:modId xmlns:p14="http://schemas.microsoft.com/office/powerpoint/2010/main" val="2280231921"/>
               </p:ext>
             </p:extLst>
           </p:nvPr>
@@ -27388,7 +27948,7 @@
                             <a:schemeClr val="tx1"/>
                           </a:solidFill>
                         </a:rPr>
-                        <a:t> = [2,1,0,2]</a:t>
+                        <a:t> = [2,0,1,2]</a:t>
                       </a:r>
                     </a:p>
                   </a:txBody>
@@ -32259,7 +32819,7 @@
             </a:pPr>
             <a:r>
               <a:rPr lang="en-US" sz="1200" dirty="0"/>
-              <a:t>This allows non-cyclic logics to be represented as circuits. E.g. the non-cyclic path [1,2,4,6,7] in the original program is represented as a circuit [1,2,4,6,7,1] in the modified CFG. </a:t>
+              <a:t>This allows non-cyclic logics to be represented as circuits. E.g. the non-cyclic path [0,1,2,4,6,7] in the original program is represented as a circuit [0,1,2,4,6,7,0] in the modified CFG. </a:t>
             </a:r>
           </a:p>
           <a:p>
@@ -39617,7 +40177,11 @@
             <a:bodyPr wrap="none" anchor="ctr"/>
             <a:lstStyle/>
             <a:p>
-              <a:endParaRPr lang="nl-NL"/>
+              <a:endParaRPr lang="nl-NL">
+                <a:solidFill>
+                  <a:srgbClr val="FFFF00"/>
+                </a:solidFill>
+              </a:endParaRPr>
             </a:p>
           </p:txBody>
         </p:sp>
@@ -39632,7 +40196,7 @@
           <p:spPr bwMode="auto">
             <a:xfrm>
               <a:off x="4815" y="2707"/>
-              <a:ext cx="196" cy="250"/>
+              <a:ext cx="197" cy="233"/>
             </a:xfrm>
             <a:prstGeom prst="rect">
               <a:avLst/>
@@ -39652,7 +40216,11 @@
             <a:lstStyle/>
             <a:p>
               <a:r>
-                <a:rPr lang="en-US"/>
+                <a:rPr lang="en-US">
+                  <a:solidFill>
+                    <a:srgbClr val="FFFF00"/>
+                  </a:solidFill>
+                </a:rPr>
                 <a:t>2</a:t>
               </a:r>
             </a:p>
@@ -39707,7 +40275,11 @@
             <a:bodyPr wrap="none" anchor="ctr"/>
             <a:lstStyle/>
             <a:p>
-              <a:endParaRPr lang="nl-NL"/>
+              <a:endParaRPr lang="nl-NL">
+                <a:solidFill>
+                  <a:srgbClr val="FFFF00"/>
+                </a:solidFill>
+              </a:endParaRPr>
             </a:p>
           </p:txBody>
         </p:sp>
@@ -39722,7 +40294,7 @@
           <p:spPr bwMode="auto">
             <a:xfrm>
               <a:off x="3915" y="2707"/>
-              <a:ext cx="196" cy="250"/>
+              <a:ext cx="197" cy="233"/>
             </a:xfrm>
             <a:prstGeom prst="rect">
               <a:avLst/>
@@ -39742,7 +40314,11 @@
             <a:lstStyle/>
             <a:p>
               <a:r>
-                <a:rPr lang="en-US"/>
+                <a:rPr lang="en-US">
+                  <a:solidFill>
+                    <a:srgbClr val="FFFF00"/>
+                  </a:solidFill>
+                </a:rPr>
                 <a:t>1</a:t>
               </a:r>
             </a:p>
@@ -39831,7 +40407,11 @@
             <a:bodyPr wrap="none" anchor="ctr"/>
             <a:lstStyle/>
             <a:p>
-              <a:endParaRPr lang="nl-NL"/>
+              <a:endParaRPr lang="nl-NL">
+                <a:solidFill>
+                  <a:srgbClr val="FFFF00"/>
+                </a:solidFill>
+              </a:endParaRPr>
             </a:p>
           </p:txBody>
         </p:sp>
@@ -39845,8 +40425,8 @@
           </p:nvSpPr>
           <p:spPr bwMode="auto">
             <a:xfrm>
-              <a:off x="4365" y="1769"/>
-              <a:ext cx="196" cy="250"/>
+              <a:off x="4364" y="1769"/>
+              <a:ext cx="197" cy="233"/>
             </a:xfrm>
             <a:prstGeom prst="rect">
               <a:avLst/>
@@ -39867,7 +40447,11 @@
             <a:p>
               <a:pPr algn="r"/>
               <a:r>
-                <a:rPr lang="en-US"/>
+                <a:rPr lang="en-US">
+                  <a:solidFill>
+                    <a:srgbClr val="FFFF00"/>
+                  </a:solidFill>
+                </a:rPr>
                 <a:t>3</a:t>
               </a:r>
             </a:p>
@@ -40244,7 +40828,11 @@
             <a:bodyPr wrap="none" anchor="ctr"/>
             <a:lstStyle/>
             <a:p>
-              <a:endParaRPr lang="nl-NL"/>
+              <a:endParaRPr lang="nl-NL">
+                <a:solidFill>
+                  <a:srgbClr val="FFFF00"/>
+                </a:solidFill>
+              </a:endParaRPr>
             </a:p>
           </p:txBody>
         </p:sp>
@@ -40280,7 +40868,11 @@
             <a:p>
               <a:pPr algn="r"/>
               <a:r>
-                <a:rPr lang="en-US" dirty="0"/>
+                <a:rPr lang="en-US" dirty="0">
+                  <a:solidFill>
+                    <a:srgbClr val="FFFF00"/>
+                  </a:solidFill>
+                </a:rPr>
                 <a:t>4</a:t>
               </a:r>
             </a:p>
@@ -41124,7 +41716,11 @@
             <a:bodyPr wrap="none" anchor="ctr"/>
             <a:lstStyle/>
             <a:p>
-              <a:endParaRPr lang="nl-NL"/>
+              <a:endParaRPr lang="nl-NL">
+                <a:solidFill>
+                  <a:srgbClr val="FFFF00"/>
+                </a:solidFill>
+              </a:endParaRPr>
             </a:p>
           </p:txBody>
         </p:sp>
@@ -41139,7 +41735,7 @@
           <p:spPr bwMode="auto">
             <a:xfrm>
               <a:off x="4815" y="2707"/>
-              <a:ext cx="196" cy="250"/>
+              <a:ext cx="197" cy="233"/>
             </a:xfrm>
             <a:prstGeom prst="rect">
               <a:avLst/>
@@ -41159,7 +41755,11 @@
             <a:lstStyle/>
             <a:p>
               <a:r>
-                <a:rPr lang="en-US"/>
+                <a:rPr lang="en-US">
+                  <a:solidFill>
+                    <a:srgbClr val="FFFF00"/>
+                  </a:solidFill>
+                </a:rPr>
                 <a:t>2</a:t>
               </a:r>
             </a:p>
@@ -41214,7 +41814,11 @@
             <a:bodyPr wrap="none" anchor="ctr"/>
             <a:lstStyle/>
             <a:p>
-              <a:endParaRPr lang="nl-NL"/>
+              <a:endParaRPr lang="nl-NL">
+                <a:solidFill>
+                  <a:srgbClr val="FFFF00"/>
+                </a:solidFill>
+              </a:endParaRPr>
             </a:p>
           </p:txBody>
         </p:sp>
@@ -41229,7 +41833,7 @@
           <p:spPr bwMode="auto">
             <a:xfrm>
               <a:off x="3915" y="2707"/>
-              <a:ext cx="196" cy="250"/>
+              <a:ext cx="197" cy="233"/>
             </a:xfrm>
             <a:prstGeom prst="rect">
               <a:avLst/>
@@ -41249,7 +41853,11 @@
             <a:lstStyle/>
             <a:p>
               <a:r>
-                <a:rPr lang="en-US"/>
+                <a:rPr lang="en-US" dirty="0">
+                  <a:solidFill>
+                    <a:srgbClr val="FFFF00"/>
+                  </a:solidFill>
+                </a:rPr>
                 <a:t>1</a:t>
               </a:r>
             </a:p>
@@ -41338,7 +41946,11 @@
             <a:bodyPr wrap="none" anchor="ctr"/>
             <a:lstStyle/>
             <a:p>
-              <a:endParaRPr lang="nl-NL"/>
+              <a:endParaRPr lang="nl-NL">
+                <a:solidFill>
+                  <a:srgbClr val="FFFF00"/>
+                </a:solidFill>
+              </a:endParaRPr>
             </a:p>
           </p:txBody>
         </p:sp>
@@ -41352,8 +41964,8 @@
           </p:nvSpPr>
           <p:spPr bwMode="auto">
             <a:xfrm>
-              <a:off x="4365" y="1769"/>
-              <a:ext cx="196" cy="250"/>
+              <a:off x="4364" y="1769"/>
+              <a:ext cx="197" cy="233"/>
             </a:xfrm>
             <a:prstGeom prst="rect">
               <a:avLst/>
@@ -41374,7 +41986,11 @@
             <a:p>
               <a:pPr algn="r"/>
               <a:r>
-                <a:rPr lang="en-US"/>
+                <a:rPr lang="en-US">
+                  <a:solidFill>
+                    <a:srgbClr val="FFFF00"/>
+                  </a:solidFill>
+                </a:rPr>
                 <a:t>3</a:t>
               </a:r>
             </a:p>
@@ -41697,7 +42313,11 @@
             <a:bodyPr wrap="none" anchor="ctr"/>
             <a:lstStyle/>
             <a:p>
-              <a:endParaRPr lang="nl-NL"/>
+              <a:endParaRPr lang="nl-NL">
+                <a:solidFill>
+                  <a:srgbClr val="FFFF00"/>
+                </a:solidFill>
+              </a:endParaRPr>
             </a:p>
           </p:txBody>
         </p:sp>
@@ -41733,7 +42353,11 @@
             <a:p>
               <a:pPr algn="r"/>
               <a:r>
-                <a:rPr lang="en-US" dirty="0"/>
+                <a:rPr lang="en-US" dirty="0">
+                  <a:solidFill>
+                    <a:srgbClr val="FFFF00"/>
+                  </a:solidFill>
+                </a:rPr>
                 <a:t>4</a:t>
               </a:r>
             </a:p>

</xml_diff>